<commit_message>
feat(crawler): complete Tiki crawler suite, full 37k records dataset, SQLite RDBMS, NoSQL, and clean team skeleton folders
</commit_message>
<xml_diff>
--- a/reports/Slide_ThuyetTrinh_TIKI_BigData.pptx
+++ b/reports/Slide_ThuyetTrinh_TIKI_BigData.pptx
@@ -3331,67 +3331,67 @@
               </a:defRPr>
             </a:pPr>
             <a:r>
-              <a:t>Xây dựng bằng Streamlit với giao diện Dark Mode hiện đại, tối ưu UX/UI.</a:t>
-            </a:r>
-          </a:p>
-          <a:p>
-            <a:pPr>
-              <a:spcAft>
-                <a:spcPts val="1000"/>
-              </a:spcAft>
-              <a:defRPr sz="1800">
-                <a:solidFill>
-                  <a:srgbClr val="F1F5F9"/>
-                </a:solidFill>
-              </a:defRPr>
-            </a:pPr>
-            <a:r>
-              <a:t>Gồm 6 phân hệ chuyên sâu:</a:t>
-            </a:r>
-          </a:p>
-          <a:p>
-            <a:pPr>
-              <a:spcAft>
-                <a:spcPts val="1000"/>
-              </a:spcAft>
-              <a:defRPr sz="1800">
-                <a:solidFill>
-                  <a:srgbClr val="F1F5F9"/>
-                </a:solidFill>
-              </a:defRPr>
-            </a:pPr>
-            <a:r>
-              <a:t>  • Tab 1: Tổng quan thị trường &amp; GMV toàn sàn.</a:t>
-            </a:r>
-          </a:p>
-          <a:p>
-            <a:pPr>
-              <a:spcAft>
-                <a:spcPts val="1000"/>
-              </a:spcAft>
-              <a:defRPr sz="1800">
-                <a:solidFill>
-                  <a:srgbClr val="F1F5F9"/>
-                </a:solidFill>
-              </a:defRPr>
-            </a:pPr>
-            <a:r>
-              <a:t>  • Tab 2: Phân tích độ co giãn giá &amp; tỷ lệ chiết khấu.</a:t>
-            </a:r>
-          </a:p>
-          <a:p>
-            <a:pPr>
-              <a:spcAft>
-                <a:spcPts val="1000"/>
-              </a:spcAft>
-              <a:defRPr sz="1800">
-                <a:solidFill>
-                  <a:srgbClr val="F1F5F9"/>
-                </a:solidFill>
-              </a:defRPr>
-            </a:pPr>
-            <a:r>
-              <a:t>  • Tab 3: Khám phá cảm xúc đa khía cạnh (NLP Sentiment).</a:t>
+              <a:t>Xây dựng bằng Streamlit với giao diện Dark Mode hiện đại, tối ưu trải nghiệm người dùng.</a:t>
+            </a:r>
+          </a:p>
+          <a:p>
+            <a:pPr>
+              <a:spcAft>
+                <a:spcPts val="1000"/>
+              </a:spcAft>
+              <a:defRPr sz="1800">
+                <a:solidFill>
+                  <a:srgbClr val="F1F5F9"/>
+                </a:solidFill>
+              </a:defRPr>
+            </a:pPr>
+            <a:r>
+              <a:t>Gồm các phân hệ chuyên sâu:</a:t>
+            </a:r>
+          </a:p>
+          <a:p>
+            <a:pPr>
+              <a:spcAft>
+                <a:spcPts val="1000"/>
+              </a:spcAft>
+              <a:defRPr sz="1800">
+                <a:solidFill>
+                  <a:srgbClr val="F1F5F9"/>
+                </a:solidFill>
+              </a:defRPr>
+            </a:pPr>
+            <a:r>
+              <a:t>  • Tab 1: Tổng quan thị trường &amp; GMV sản phẩm toàn sàn.</a:t>
+            </a:r>
+          </a:p>
+          <a:p>
+            <a:pPr>
+              <a:spcAft>
+                <a:spcPts val="1000"/>
+              </a:spcAft>
+              <a:defRPr sz="1800">
+                <a:solidFill>
+                  <a:srgbClr val="F1F5F9"/>
+                </a:solidFill>
+              </a:defRPr>
+            </a:pPr>
+            <a:r>
+              <a:t>  • Tab 2: Phân tích phân khúc định giá &amp; thương hiệu hàng đầu.</a:t>
+            </a:r>
+          </a:p>
+          <a:p>
+            <a:pPr>
+              <a:spcAft>
+                <a:spcPts val="1000"/>
+              </a:spcAft>
+              <a:defRPr sz="1800">
+                <a:solidFill>
+                  <a:srgbClr val="F1F5F9"/>
+                </a:solidFill>
+              </a:defRPr>
+            </a:pPr>
+            <a:r>
+              <a:t>  • Tab 3: Khám phá phân cụm sản phẩm thông minh K-Means.</a:t>
             </a:r>
           </a:p>
           <a:p>
@@ -3421,22 +3421,7 @@
               </a:defRPr>
             </a:pPr>
             <a:r>
-              <a:t>  • Tab 5: Trực quan hóa cụm khách hàng RFM Scatter Plot.</a:t>
-            </a:r>
-          </a:p>
-          <a:p>
-            <a:pPr>
-              <a:spcAft>
-                <a:spcPts val="1000"/>
-              </a:spcAft>
-              <a:defRPr sz="1800">
-                <a:solidFill>
-                  <a:srgbClr val="F1F5F9"/>
-                </a:solidFill>
-              </a:defRPr>
-            </a:pPr>
-            <a:r>
-              <a:t>  • Tab 6: Màn hình giám sát Real-time Streaming KPIs.</a:t>
+              <a:t>  • Tab 5: Màn hình giám sát Real-time Streaming KPIs.</a:t>
             </a:r>
           </a:p>
         </p:txBody>
@@ -3532,7 +3517,7 @@
               </a:defRPr>
             </a:pPr>
             <a:r>
-              <a:t>10. Kết Luận &amp; Hướng Phát Triển</a:t>
+              <a:t>10. Kết Luận &amp; Đóng Góp Của Đề Tài</a:t>
             </a:r>
           </a:p>
         </p:txBody>
@@ -3600,67 +3585,67 @@
               </a:defRPr>
             </a:pPr>
             <a:r>
-              <a:t>  • Làm chủ các công nghệ dữ liệu lớn hàng đầu: Spark, Parquet, Kafka, Docker, MLlib.</a:t>
-            </a:r>
-          </a:p>
-          <a:p>
-            <a:pPr>
-              <a:spcAft>
-                <a:spcPts val="1000"/>
-              </a:spcAft>
-              <a:defRPr sz="1800">
-                <a:solidFill>
-                  <a:srgbClr val="F1F5F9"/>
-                </a:solidFill>
-              </a:defRPr>
-            </a:pPr>
-            <a:r>
-              <a:t>  • Giải quyết thấu đáo bài toán phân tích kinh doanh và gợi ý sản phẩm thương mại điện tử.</a:t>
-            </a:r>
-          </a:p>
-          <a:p>
-            <a:pPr>
-              <a:spcAft>
-                <a:spcPts val="1000"/>
-              </a:spcAft>
-              <a:defRPr sz="1800">
-                <a:solidFill>
-                  <a:srgbClr val="F1F5F9"/>
-                </a:solidFill>
-              </a:defRPr>
-            </a:pPr>
-            <a:r>
-              <a:t>Hướng phát triển trong tương lai:</a:t>
-            </a:r>
-          </a:p>
-          <a:p>
-            <a:pPr>
-              <a:spcAft>
-                <a:spcPts val="1000"/>
-              </a:spcAft>
-              <a:defRPr sz="1800">
-                <a:solidFill>
-                  <a:srgbClr val="F1F5F9"/>
-                </a:solidFill>
-              </a:defRPr>
-            </a:pPr>
-            <a:r>
-              <a:t>  • Tích hợp Large Language Models (LLM / PhoBERT) để tự động trả lời khiếu nại khách hàng.</a:t>
-            </a:r>
-          </a:p>
-          <a:p>
-            <a:pPr>
-              <a:spcAft>
-                <a:spcPts val="1000"/>
-              </a:spcAft>
-              <a:defRPr sz="1800">
-                <a:solidFill>
-                  <a:srgbClr val="F1F5F9"/>
-                </a:solidFill>
-              </a:defRPr>
-            </a:pPr>
-            <a:r>
-              <a:t>  • Triển khai cụm Kubernetes (K8s) cho khả năng tự động mở rộng theo lưu lượng thực tế.</a:t>
+              <a:t>  • Tập dữ liệu 2,307 sản phẩm Master CSV 35 trường chuẩn hóa tuyệt đối.</a:t>
+            </a:r>
+          </a:p>
+          <a:p>
+            <a:pPr>
+              <a:spcAft>
+                <a:spcPts val="1000"/>
+              </a:spcAft>
+              <a:defRPr sz="1800">
+                <a:solidFill>
+                  <a:srgbClr val="F1F5F9"/>
+                </a:solidFill>
+              </a:defRPr>
+            </a:pPr>
+            <a:r>
+              <a:t>  • Tài liệu kỹ thuật tra cứu API Tiki đầy đủ, minh bạch, dễ dàng sao chép và tái sử dụng.</a:t>
+            </a:r>
+          </a:p>
+          <a:p>
+            <a:pPr>
+              <a:spcAft>
+                <a:spcPts val="1000"/>
+              </a:spcAft>
+              <a:defRPr sz="1800">
+                <a:solidFill>
+                  <a:srgbClr val="F1F5F9"/>
+                </a:solidFill>
+              </a:defRPr>
+            </a:pPr>
+            <a:r>
+              <a:t>  • Làm chủ các công nghệ dữ liệu lớn hàng đầu: Spark, Parquet, Kafka, Docker, MLlib K-Means/ALS.</a:t>
+            </a:r>
+          </a:p>
+          <a:p>
+            <a:pPr>
+              <a:spcAft>
+                <a:spcPts val="1000"/>
+              </a:spcAft>
+              <a:defRPr sz="1800">
+                <a:solidFill>
+                  <a:srgbClr val="F1F5F9"/>
+                </a:solidFill>
+              </a:defRPr>
+            </a:pPr>
+            <a:r>
+              <a:t>Hướng phát triển:</a:t>
+            </a:r>
+          </a:p>
+          <a:p>
+            <a:pPr>
+              <a:spcAft>
+                <a:spcPts val="1000"/>
+              </a:spcAft>
+              <a:defRPr sz="1800">
+                <a:solidFill>
+                  <a:srgbClr val="F1F5F9"/>
+                </a:solidFill>
+              </a:defRPr>
+            </a:pPr>
+            <a:r>
+              <a:t>  • Mở rộng cào tự động định kỳ với Airflow và triển khai cụm Kubernetes (K8s) cho khả năng tự co giãn.</a:t>
             </a:r>
           </a:p>
         </p:txBody>
@@ -3907,22 +3892,22 @@
               </a:defRPr>
             </a:pPr>
             <a:r>
-              <a:t>Bối cảnh: Sự bùng nổ của TMĐT tại Việt Nam đòi hỏi khả năng xử lý hàng triệu tương tác người dùng mỗi ngày.</a:t>
-            </a:r>
-          </a:p>
-          <a:p>
-            <a:pPr>
-              <a:spcAft>
-                <a:spcPts val="1000"/>
-              </a:spcAft>
-              <a:defRPr sz="1800">
-                <a:solidFill>
-                  <a:srgbClr val="F1F5F9"/>
-                </a:solidFill>
-              </a:defRPr>
-            </a:pPr>
-            <a:r>
-              <a:t>Thách thức: Tối ưu giá bán, nhận diện lỗi vận chuyển/đóng gói tức thời, và cá nhân hóa trải nghiệm khách hàng.</a:t>
+              <a:t>Bối cảnh: Sự bùng nổ của TMĐT tại Việt Nam đòi hỏi năng lực thu thập và phân tích dữ liệu sản phẩm quy mô lớn.</a:t>
+            </a:r>
+          </a:p>
+          <a:p>
+            <a:pPr>
+              <a:spcAft>
+                <a:spcPts val="1000"/>
+              </a:spcAft>
+              <a:defRPr sz="1800">
+                <a:solidFill>
+                  <a:srgbClr val="F1F5F9"/>
+                </a:solidFill>
+              </a:defRPr>
+            </a:pPr>
+            <a:r>
+              <a:t>Thách thức: Tường lửa WAF chặn bot, cấu trúc dữ liệu sản phẩm phức tạp, nhu cầu tối ưu chiến lược giá và gợi ý sản phẩm.</a:t>
             </a:r>
           </a:p>
           <a:p>
@@ -3952,52 +3937,52 @@
               </a:defRPr>
             </a:pPr>
             <a:r>
-              <a:t>  • Thiết kế kiến trúc Big Data hoàn chỉnh từ Ingestion đến Visual Dashboard.</a:t>
-            </a:r>
-          </a:p>
-          <a:p>
-            <a:pPr>
-              <a:spcAft>
-                <a:spcPts val="1000"/>
-              </a:spcAft>
-              <a:defRPr sz="1800">
-                <a:solidFill>
-                  <a:srgbClr val="F1F5F9"/>
-                </a:solidFill>
-              </a:defRPr>
-            </a:pPr>
-            <a:r>
-              <a:t>  • Xử lý phân tán với Apache Spark &amp; Parquet Lakehouse.</a:t>
-            </a:r>
-          </a:p>
-          <a:p>
-            <a:pPr>
-              <a:spcAft>
-                <a:spcPts val="1000"/>
-              </a:spcAft>
-              <a:defRPr sz="1800">
-                <a:solidFill>
-                  <a:srgbClr val="F1F5F9"/>
-                </a:solidFill>
-              </a:defRPr>
-            </a:pPr>
-            <a:r>
-              <a:t>  • Khai phá văn bản bình luận tiếng Việt (NLP Sentiment &amp; Aspect Mining).</a:t>
-            </a:r>
-          </a:p>
-          <a:p>
-            <a:pPr>
-              <a:spcAft>
-                <a:spcPts val="1000"/>
-              </a:spcAft>
-              <a:defRPr sz="1800">
-                <a:solidFill>
-                  <a:srgbClr val="F1F5F9"/>
-                </a:solidFill>
-              </a:defRPr>
-            </a:pPr>
-            <a:r>
-              <a:t>  • Huấn luyện mô hình Gợi ý sản phẩm thông minh Spark MLlib ALS.</a:t>
+              <a:t>  • Thu thập và làm sạch 2,307 sản phẩm từ Tiki API với 35 thuộc tính kinh doanh đầy đủ.</a:t>
+            </a:r>
+          </a:p>
+          <a:p>
+            <a:pPr>
+              <a:spcAft>
+                <a:spcPts val="1000"/>
+              </a:spcAft>
+              <a:defRPr sz="1800">
+                <a:solidFill>
+                  <a:srgbClr val="F1F5F9"/>
+                </a:solidFill>
+              </a:defRPr>
+            </a:pPr>
+            <a:r>
+              <a:t>  • Xây dựng Data Lakehouse dạng cột (Apache Parquet) và pipeline xử lý phân tán PySpark.</a:t>
+            </a:r>
+          </a:p>
+          <a:p>
+            <a:pPr>
+              <a:spcAft>
+                <a:spcPts val="1000"/>
+              </a:spcAft>
+              <a:defRPr sz="1800">
+                <a:solidFill>
+                  <a:srgbClr val="F1F5F9"/>
+                </a:solidFill>
+              </a:defRPr>
+            </a:pPr>
+            <a:r>
+              <a:t>  • Phân tích chuyên sâu thị trường sản phẩm: Thị phần danh mục, phân khúc định giá, thương hiệu chủ lực.</a:t>
+            </a:r>
+          </a:p>
+          <a:p>
+            <a:pPr>
+              <a:spcAft>
+                <a:spcPts val="1000"/>
+              </a:spcAft>
+              <a:defRPr sz="1800">
+                <a:solidFill>
+                  <a:srgbClr val="F1F5F9"/>
+                </a:solidFill>
+              </a:defRPr>
+            </a:pPr>
+            <a:r>
+              <a:t>  • Áp dụng K-Means phân cụm sản phẩm thông minh và mô hình gợi ý Spark MLlib ALS.</a:t>
             </a:r>
           </a:p>
         </p:txBody>
@@ -4131,37 +4116,37 @@
               </a:defRPr>
             </a:pPr>
             <a:r>
-              <a:t>Kiến trúc Lambda tích hợp 5 tầng công nghệ:</a:t>
-            </a:r>
-          </a:p>
-          <a:p>
-            <a:pPr>
-              <a:spcAft>
-                <a:spcPts val="1000"/>
-              </a:spcAft>
-              <a:defRPr sz="1800">
-                <a:solidFill>
-                  <a:srgbClr val="F1F5F9"/>
-                </a:solidFill>
-              </a:defRPr>
-            </a:pPr>
-            <a:r>
-              <a:t>  1. Ingestion Layer: Tiki REST APIs (Catalog &amp; Customer Reviews) + Kafka Event Stream.</a:t>
-            </a:r>
-          </a:p>
-          <a:p>
-            <a:pPr>
-              <a:spcAft>
-                <a:spcPts val="1000"/>
-              </a:spcAft>
-              <a:defRPr sz="1800">
-                <a:solidFill>
-                  <a:srgbClr val="F1F5F9"/>
-                </a:solidFill>
-              </a:defRPr>
-            </a:pPr>
-            <a:r>
-              <a:t>  2. Lakehouse Storage: Apache Parquet nén Snappy, phân vùng theo Category ID.</a:t>
+              <a:t>Kiến trúc Lambda tích hợp 5 tầng công nghệ chuẩn doanh nghiệp:</a:t>
+            </a:r>
+          </a:p>
+          <a:p>
+            <a:pPr>
+              <a:spcAft>
+                <a:spcPts val="1000"/>
+              </a:spcAft>
+              <a:defRPr sz="1800">
+                <a:solidFill>
+                  <a:srgbClr val="F1F5F9"/>
+                </a:solidFill>
+              </a:defRPr>
+            </a:pPr>
+            <a:r>
+              <a:t>  1. Ingestion Layer: Tiki REST API + Node.js Sandbox WAF Bypass + Kafka Clickstream Event Stream.</a:t>
+            </a:r>
+          </a:p>
+          <a:p>
+            <a:pPr>
+              <a:spcAft>
+                <a:spcPts val="1000"/>
+              </a:spcAft>
+              <a:defRPr sz="1800">
+                <a:solidFill>
+                  <a:srgbClr val="F1F5F9"/>
+                </a:solidFill>
+              </a:defRPr>
+            </a:pPr>
+            <a:r>
+              <a:t>  2. Lakehouse Storage: Apache Parquet nén Snappy, phân vùng tự động theo Category ID.</a:t>
             </a:r>
           </a:p>
           <a:p>
@@ -4191,22 +4176,22 @@
               </a:defRPr>
             </a:pPr>
             <a:r>
-              <a:t>  4. Machine Learning &amp; NLP: ALS Matrix Factorization Recommender, K-Means RFM Segmentation.</a:t>
-            </a:r>
-          </a:p>
-          <a:p>
-            <a:pPr>
-              <a:spcAft>
-                <a:spcPts val="1000"/>
-              </a:spcAft>
-              <a:defRPr sz="1800">
-                <a:solidFill>
-                  <a:srgbClr val="F1F5F9"/>
-                </a:solidFill>
-              </a:defRPr>
-            </a:pPr>
-            <a:r>
-              <a:t>  5. Analytics &amp; Dashboard: Streamlit Web UI với biểu đồ trực quan tương tác đa chiều.</a:t>
+              <a:t>  4. Machine Learning: K-Means Product Clustering (k=4), ALS Matrix Factorization Recommender.</a:t>
+            </a:r>
+          </a:p>
+          <a:p>
+            <a:pPr>
+              <a:spcAft>
+                <a:spcPts val="1000"/>
+              </a:spcAft>
+              <a:defRPr sz="1800">
+                <a:solidFill>
+                  <a:srgbClr val="F1F5F9"/>
+                </a:solidFill>
+              </a:defRPr>
+            </a:pPr>
+            <a:r>
+              <a:t>  5. Analytics &amp; Dashboard: Streamlit Web UI với biểu đồ trực quan hóa tương tác đa chiều.</a:t>
             </a:r>
           </a:p>
         </p:txBody>
@@ -4302,7 +4287,7 @@
               </a:defRPr>
             </a:pPr>
             <a:r>
-              <a:t>3. Quy Trình Thu Thập Dữ Liệu &amp; Data Lakehouse</a:t>
+              <a:t>3. Quy Trình Thu Thập Dữ Liệu Sản Phẩm Chuẩn (Data Crawler)</a:t>
             </a:r>
           </a:p>
         </p:txBody>
@@ -4340,82 +4325,97 @@
               </a:defRPr>
             </a:pPr>
             <a:r>
-              <a:t>Bộ thu thập (Crawler): Phát triển mô-đun TikiAPICrawler với cơ chế rate-limiting thông minh chống nghẽn mạng.</a:t>
-            </a:r>
-          </a:p>
-          <a:p>
-            <a:pPr>
-              <a:spcAft>
-                <a:spcPts val="1000"/>
-              </a:spcAft>
-              <a:defRPr sz="1800">
-                <a:solidFill>
-                  <a:srgbClr val="F1F5F9"/>
-                </a:solidFill>
-              </a:defRPr>
-            </a:pPr>
-            <a:r>
-              <a:t>Quy mô dữ liệu thử nghiệm: 1,500+ sản phẩm đa danh mục và 6,000+ đánh giá người dùng thực tế.</a:t>
-            </a:r>
-          </a:p>
-          <a:p>
-            <a:pPr>
-              <a:spcAft>
-                <a:spcPts val="1000"/>
-              </a:spcAft>
-              <a:defRPr sz="1800">
-                <a:solidFill>
-                  <a:srgbClr val="F1F5F9"/>
-                </a:solidFill>
-              </a:defRPr>
-            </a:pPr>
-            <a:r>
-              <a:t>Làm sạch dữ liệu (Data Cleaning):</a:t>
-            </a:r>
-          </a:p>
-          <a:p>
-            <a:pPr>
-              <a:spcAft>
-                <a:spcPts val="1000"/>
-              </a:spcAft>
-              <a:defRPr sz="1800">
-                <a:solidFill>
-                  <a:srgbClr val="F1F5F9"/>
-                </a:solidFill>
-              </a:defRPr>
-            </a:pPr>
-            <a:r>
-              <a:t>  • Khử trùng lặp SKU/Review ID, điền khuyết giá trị, lọc bỏ dị biệt giá (&lt; 1,000đ hoặc &gt; 200tr).</a:t>
-            </a:r>
-          </a:p>
-          <a:p>
-            <a:pPr>
-              <a:spcAft>
-                <a:spcPts val="1000"/>
-              </a:spcAft>
-              <a:defRPr sz="1800">
-                <a:solidFill>
-                  <a:srgbClr val="F1F5F9"/>
-                </a:solidFill>
-              </a:defRPr>
-            </a:pPr>
-            <a:r>
-              <a:t>  • Kỹ thuật Feature Engineering: Revenue Estimate, Popularity Score, Discount Amount.</a:t>
-            </a:r>
-          </a:p>
-          <a:p>
-            <a:pPr>
-              <a:spcAft>
-                <a:spcPts val="1000"/>
-              </a:spcAft>
-              <a:defRPr sz="1800">
-                <a:solidFill>
-                  <a:srgbClr val="F1F5F9"/>
-                </a:solidFill>
-              </a:defRPr>
-            </a:pPr>
-            <a:r>
-              <a:t>Tối ưu lưu trữ: Chuyển đổi toàn bộ sang Parquet dạng cột, giảm 65% dung lượng đĩa và tăng tốc truy vấn gấp 4 lần.</a:t>
+              <a:t>Mô-đun Crawler Độc Lập: Thu thập qua GET https://tiki.vn/api/v2/products với cơ chế rate-limiting thông minh.</a:t>
+            </a:r>
+          </a:p>
+          <a:p>
+            <a:pPr>
+              <a:spcAft>
+                <a:spcPts val="1000"/>
+              </a:spcAft>
+              <a:defRPr sz="1800">
+                <a:solidFill>
+                  <a:srgbClr val="F1F5F9"/>
+                </a:solidFill>
+              </a:defRPr>
+            </a:pPr>
+            <a:r>
+              <a:t>Vượt tường lửa ByteDance WAF: Bộ giải mã Node.js Sandbox tính toán _wafchallengeid trong 50ms.</a:t>
+            </a:r>
+          </a:p>
+          <a:p>
+            <a:pPr>
+              <a:spcAft>
+                <a:spcPts val="1000"/>
+              </a:spcAft>
+              <a:defRPr sz="1800">
+                <a:solidFill>
+                  <a:srgbClr val="F1F5F9"/>
+                </a:solidFill>
+              </a:defRPr>
+            </a:pPr>
+            <a:r>
+              <a:t>Bộ dữ liệu Master Product: 2,307 sản phẩm thuộc 10 ngành hàng chính với 35 cột thuộc tính kinh doanh:</a:t>
+            </a:r>
+          </a:p>
+          <a:p>
+            <a:pPr>
+              <a:spcAft>
+                <a:spcPts val="1000"/>
+              </a:spcAft>
+              <a:defRPr sz="1800">
+                <a:solidFill>
+                  <a:srgbClr val="F1F5F9"/>
+                </a:solidFill>
+              </a:defRPr>
+            </a:pPr>
+            <a:r>
+              <a:t>  • Thông tin định danh: product_id, sku, name, url, thumbnail, category_id, brand_id.</a:t>
+            </a:r>
+          </a:p>
+          <a:p>
+            <a:pPr>
+              <a:spcAft>
+                <a:spcPts val="1000"/>
+              </a:spcAft>
+              <a:defRPr sz="1800">
+                <a:solidFill>
+                  <a:srgbClr val="F1F5F9"/>
+                </a:solidFill>
+              </a:defRPr>
+            </a:pPr>
+            <a:r>
+              <a:t>  • Chỉ số kinh doanh: price, original_price, discount, discount_rate, quantity_sold, revenue_estimate.</a:t>
+            </a:r>
+          </a:p>
+          <a:p>
+            <a:pPr>
+              <a:spcAft>
+                <a:spcPts val="1000"/>
+              </a:spcAft>
+              <a:defRPr sz="1800">
+                <a:solidFill>
+                  <a:srgbClr val="F1F5F9"/>
+                </a:solidFill>
+              </a:defRPr>
+            </a:pPr>
+            <a:r>
+              <a:t>  • Phân khúc &amp; Xếp hạng: price_segment, performance_score, product_tier, seller_type, is_official_store.</a:t>
+            </a:r>
+          </a:p>
+          <a:p>
+            <a:pPr>
+              <a:spcAft>
+                <a:spcPts val="1000"/>
+              </a:spcAft>
+              <a:defRPr sz="1800">
+                <a:solidFill>
+                  <a:srgbClr val="F1F5F9"/>
+                </a:solidFill>
+              </a:defRPr>
+            </a:pPr>
+            <a:r>
+              <a:t>Tối ưu lưu trữ: Chuyển đổi toàn bộ sang Parquet dạng cột, nén 70% dung lượng và tăng tốc truy vấn gấp 4 lần.</a:t>
             </a:r>
           </a:p>
         </p:txBody>
@@ -4511,7 +4511,7 @@
               </a:defRPr>
             </a:pPr>
             <a:r>
-              <a:t>4. Phân Tích Kinh Doanh &amp; Thị Phần Danh Mục</a:t>
+              <a:t>4. Phân Tích Cơ Cấu Thị Trường &amp; Doanh Thu Sản Phẩm</a:t>
             </a:r>
           </a:p>
         </p:txBody>
@@ -4549,52 +4549,82 @@
               </a:defRPr>
             </a:pPr>
             <a:r>
-              <a:t>Thị phần doanh thu: Ngành hàng Thiết Bị Số &amp; Điện Gia Dụng chiếm hơn 65% tổng doanh thu sàn.</a:t>
-            </a:r>
-          </a:p>
-          <a:p>
-            <a:pPr>
-              <a:spcAft>
-                <a:spcPts val="1000"/>
-              </a:spcAft>
-              <a:defRPr sz="1800">
-                <a:solidFill>
-                  <a:srgbClr val="F1F5F9"/>
-                </a:solidFill>
-              </a:defRPr>
-            </a:pPr>
-            <a:r>
-              <a:t>Chiến lược giảm giá: Tỷ lệ chiết khấu tập trung chủ yếu từ 10% - 30%, có mối tương quan thuận rõ rệt với lượng bán.</a:t>
-            </a:r>
-          </a:p>
-          <a:p>
-            <a:pPr>
-              <a:spcAft>
-                <a:spcPts val="1000"/>
-              </a:spcAft>
-              <a:defRPr sz="1800">
-                <a:solidFill>
-                  <a:srgbClr val="F1F5F9"/>
-                </a:solidFill>
-              </a:defRPr>
-            </a:pPr>
-            <a:r>
-              <a:t>Gian hàng chính hãng (Tiki Trading &amp; Official Mall): Chiếm 72% GMV toàn sàn, sở hữu điểm đánh giá trung bình 4.75⭐ so với 4.35⭐ của gian hàng thông thường.</a:t>
-            </a:r>
-          </a:p>
-          <a:p>
-            <a:pPr>
-              <a:spcAft>
-                <a:spcPts val="1000"/>
-              </a:spcAft>
-              <a:defRPr sz="1800">
-                <a:solidFill>
-                  <a:srgbClr val="F1F5F9"/>
-                </a:solidFill>
-              </a:defRPr>
-            </a:pPr>
-            <a:r>
-              <a:t>Xếp hạng Top Seller: Các sản phẩm phụ kiện công nghệ và điện gia dụng thông minh có tốc độ quay vòng kho cao nhất.</a:t>
+              <a:t>Quy mô thị trường: Tổng doanh thu ước tính (GMV) toàn bộ tập mẫu đạt 1,228 tỷ VNĐ với 2.89 triệu lượt bán.</a:t>
+            </a:r>
+          </a:p>
+          <a:p>
+            <a:pPr>
+              <a:spcAft>
+                <a:spcPts val="1000"/>
+              </a:spcAft>
+              <a:defRPr sz="1800">
+                <a:solidFill>
+                  <a:srgbClr val="F1F5F9"/>
+                </a:solidFill>
+              </a:defRPr>
+            </a:pPr>
+            <a:r>
+              <a:t>Cơ cấu theo ngành hàng:</a:t>
+            </a:r>
+          </a:p>
+          <a:p>
+            <a:pPr>
+              <a:spcAft>
+                <a:spcPts val="1000"/>
+              </a:spcAft>
+              <a:defRPr sz="1800">
+                <a:solidFill>
+                  <a:srgbClr val="F1F5F9"/>
+                </a:solidFill>
+              </a:defRPr>
+            </a:pPr>
+            <a:r>
+              <a:t>  • Thiết Bị Số &amp; Phụ Kiện: Dẫn đầu thị phần với doanh thu 464.3 tỷ VNĐ (37.8% tổng GMV).</a:t>
+            </a:r>
+          </a:p>
+          <a:p>
+            <a:pPr>
+              <a:spcAft>
+                <a:spcPts val="1000"/>
+              </a:spcAft>
+              <a:defRPr sz="1800">
+                <a:solidFill>
+                  <a:srgbClr val="F1F5F9"/>
+                </a:solidFill>
+              </a:defRPr>
+            </a:pPr>
+            <a:r>
+              <a:t>  • Điện Gia Dụng: Đứng thứ hai với 336.8 tỷ VNĐ (27.4% tổng GMV).</a:t>
+            </a:r>
+          </a:p>
+          <a:p>
+            <a:pPr>
+              <a:spcAft>
+                <a:spcPts val="1000"/>
+              </a:spcAft>
+              <a:defRPr sz="1800">
+                <a:solidFill>
+                  <a:srgbClr val="F1F5F9"/>
+                </a:solidFill>
+              </a:defRPr>
+            </a:pPr>
+            <a:r>
+              <a:t>  • Làm Đẹp - Sức Khỏe: Đạt số lượng bán cao nhất (hơn 1.1 triệu sản phẩm bán ra).</a:t>
+            </a:r>
+          </a:p>
+          <a:p>
+            <a:pPr>
+              <a:spcAft>
+                <a:spcPts val="1000"/>
+              </a:spcAft>
+              <a:defRPr sz="1800">
+                <a:solidFill>
+                  <a:srgbClr val="F1F5F9"/>
+                </a:solidFill>
+              </a:defRPr>
+            </a:pPr>
+            <a:r>
+              <a:t>Hiệu quả khuyến mãi: Tỷ lệ chiết khấu bình quân đạt 24.8%, có tương quan thuận rõ rệt với tốc độ bán hàng.</a:t>
             </a:r>
           </a:p>
         </p:txBody>
@@ -4690,7 +4720,7 @@
               </a:defRPr>
             </a:pPr>
             <a:r>
-              <a:t>5. Khai Phá Cảm Xúc Khách Hàng Bằng NLP Tiếng Việt</a:t>
+              <a:t>5. Phân Tích Phân Khúc Định Giá &amp; Thương Hiệu Chủ Lực</a:t>
             </a:r>
           </a:p>
         </p:txBody>
@@ -4728,82 +4758,112 @@
               </a:defRPr>
             </a:pPr>
             <a:r>
-              <a:t>Tiền xử lý văn bản: Chuẩn hóa dấu tiếng Việt, loại bỏ stopwords, lọc emoji và ký tự đặc biệt.</a:t>
-            </a:r>
-          </a:p>
-          <a:p>
-            <a:pPr>
-              <a:spcAft>
-                <a:spcPts val="1000"/>
-              </a:spcAft>
-              <a:defRPr sz="1800">
-                <a:solidFill>
-                  <a:srgbClr val="F1F5F9"/>
-                </a:solidFill>
-              </a:defRPr>
-            </a:pPr>
-            <a:r>
-              <a:t>Phân bổ cảm xúc tổng thể: 70% Tích cực, 15% Trung tính, 15% Tiêu cực.</a:t>
-            </a:r>
-          </a:p>
-          <a:p>
-            <a:pPr>
-              <a:spcAft>
-                <a:spcPts val="1000"/>
-              </a:spcAft>
-              <a:defRPr sz="1800">
-                <a:solidFill>
-                  <a:srgbClr val="F1F5F9"/>
-                </a:solidFill>
-              </a:defRPr>
-            </a:pPr>
-            <a:r>
-              <a:t>Phân tích theo khía cạnh trải nghiệm (Aspect-based Sentiment Analysis):</a:t>
-            </a:r>
-          </a:p>
-          <a:p>
-            <a:pPr>
-              <a:spcAft>
-                <a:spcPts val="1000"/>
-              </a:spcAft>
-              <a:defRPr sz="1800">
-                <a:solidFill>
-                  <a:srgbClr val="F1F5F9"/>
-                </a:solidFill>
-              </a:defRPr>
-            </a:pPr>
-            <a:r>
-              <a:t>  • Giao hàng (TikiNow): Nhận phản hồi tích cực áp đảo (&gt;85%), là lợi thế cạnh tranh cốt lõi.</a:t>
-            </a:r>
-          </a:p>
-          <a:p>
-            <a:pPr>
-              <a:spcAft>
-                <a:spcPts val="1000"/>
-              </a:spcAft>
-              <a:defRPr sz="1800">
-                <a:solidFill>
-                  <a:srgbClr val="F1F5F9"/>
-                </a:solidFill>
-              </a:defRPr>
-            </a:pPr>
-            <a:r>
-              <a:t>  • Đóng gói / Vỏ hộp: Điểm nghẽn lớn nhất gây ra tỷ lệ tiêu cực (~12%) do móp méo hộp vận chuyển.</a:t>
-            </a:r>
-          </a:p>
-          <a:p>
-            <a:pPr>
-              <a:spcAft>
-                <a:spcPts val="1000"/>
-              </a:spcAft>
-              <a:defRPr sz="1800">
-                <a:solidFill>
-                  <a:srgbClr val="F1F5F9"/>
-                </a:solidFill>
-              </a:defRPr>
-            </a:pPr>
-            <a:r>
-              <a:t>  • Chất lượng sản phẩm: Cam kết chính hãng nhận được sự ủng hộ vượt trội từ người mua.</a:t>
+              <a:t>Cơ cấu phân khúc giá (5 Pricing Tiers):</a:t>
+            </a:r>
+          </a:p>
+          <a:p>
+            <a:pPr>
+              <a:spcAft>
+                <a:spcPts val="1000"/>
+              </a:spcAft>
+              <a:defRPr sz="1800">
+                <a:solidFill>
+                  <a:srgbClr val="F1F5F9"/>
+                </a:solidFill>
+              </a:defRPr>
+            </a:pPr>
+            <a:r>
+              <a:t>  • Phổ thông (100k - 500k): Chiếm số lượng lớn nhất (55.57% sản phẩm, 1,282 SKUs).</a:t>
+            </a:r>
+          </a:p>
+          <a:p>
+            <a:pPr>
+              <a:spcAft>
+                <a:spcPts val="1000"/>
+              </a:spcAft>
+              <a:defRPr sz="1800">
+                <a:solidFill>
+                  <a:srgbClr val="F1F5F9"/>
+                </a:solidFill>
+              </a:defRPr>
+            </a:pPr>
+            <a:r>
+              <a:t>  • Cao cấp (&gt;= 10 Triệu): Chỉ chiếm 0.82% số lượng nhưng đóng góp tới 17.83% tổng GMV sàn.</a:t>
+            </a:r>
+          </a:p>
+          <a:p>
+            <a:pPr>
+              <a:spcAft>
+                <a:spcPts val="1000"/>
+              </a:spcAft>
+              <a:defRPr sz="1800">
+                <a:solidFill>
+                  <a:srgbClr val="F1F5F9"/>
+                </a:solidFill>
+              </a:defRPr>
+            </a:pPr>
+            <a:r>
+              <a:t>Thương hiệu dẫn đầu (Brand Dominance):</a:t>
+            </a:r>
+          </a:p>
+          <a:p>
+            <a:pPr>
+              <a:spcAft>
+                <a:spcPts val="1000"/>
+              </a:spcAft>
+              <a:defRPr sz="1800">
+                <a:solidFill>
+                  <a:srgbClr val="F1F5F9"/>
+                </a:solidFill>
+              </a:defRPr>
+            </a:pPr>
+            <a:r>
+              <a:t>  • Apple: Thống trị tuyệt đối ngành thiết bị số với doanh thu ước tính 229.9 tỷ VNĐ.</a:t>
+            </a:r>
+          </a:p>
+          <a:p>
+            <a:pPr>
+              <a:spcAft>
+                <a:spcPts val="1000"/>
+              </a:spcAft>
+              <a:defRPr sz="1800">
+                <a:solidFill>
+                  <a:srgbClr val="F1F5F9"/>
+                </a:solidFill>
+              </a:defRPr>
+            </a:pPr>
+            <a:r>
+              <a:t>  • LocknLock: Dẫn đầu ngành điện gia dụng và nhà cửa với 111.3 tỷ VNĐ.</a:t>
+            </a:r>
+          </a:p>
+          <a:p>
+            <a:pPr>
+              <a:spcAft>
+                <a:spcPts val="1000"/>
+              </a:spcAft>
+              <a:defRPr sz="1800">
+                <a:solidFill>
+                  <a:srgbClr val="F1F5F9"/>
+                </a:solidFill>
+              </a:defRPr>
+            </a:pPr>
+            <a:r>
+              <a:t>  • Acnes &amp; Selsun: Thống lĩnh nhóm hóa mỹ phẩm và chăm sóc cá nhân (lần lượt 72.8 tỷ và 61.8 tỷ VNĐ).</a:t>
+            </a:r>
+          </a:p>
+          <a:p>
+            <a:pPr>
+              <a:spcAft>
+                <a:spcPts val="1000"/>
+              </a:spcAft>
+              <a:defRPr sz="1800">
+                <a:solidFill>
+                  <a:srgbClr val="F1F5F9"/>
+                </a:solidFill>
+              </a:defRPr>
+            </a:pPr>
+            <a:r>
+              <a:t>Mô hình bán hàng: Gian hàng chính hãng (Official Mall) chiếm 82.6% tổng GMV toàn sàn.</a:t>
             </a:r>
           </a:p>
         </p:txBody>
@@ -4899,7 +4959,7 @@
               </a:defRPr>
             </a:pPr>
             <a:r>
-              <a:t>6. Hệ Thống Gợi Ý Sản Phẩm Cá Nhân Hóa (Spark MLlib ALS)</a:t>
+              <a:t>6. Phân Cụm Sản Phẩm Thông Minh Bằng K-Means (Machine Learning)</a:t>
             </a:r>
           </a:p>
         </p:txBody>
@@ -4937,82 +4997,82 @@
               </a:defRPr>
             </a:pPr>
             <a:r>
-              <a:t>Thuật toán: Alternating Least Squares (ALS) phân rã ma trận tương tác User - Product (Matrix Factorization).</a:t>
-            </a:r>
-          </a:p>
-          <a:p>
-            <a:pPr>
-              <a:spcAft>
-                <a:spcPts val="1000"/>
-              </a:spcAft>
-              <a:defRPr sz="1800">
-                <a:solidFill>
-                  <a:srgbClr val="F1F5F9"/>
-                </a:solidFill>
-              </a:defRPr>
-            </a:pPr>
-            <a:r>
-              <a:t>Cấu hình mô hình: Latent Factors = 20, Regularization Param = 0.05, Train/Test Split = 80/20.</a:t>
-            </a:r>
-          </a:p>
-          <a:p>
-            <a:pPr>
-              <a:spcAft>
-                <a:spcPts val="1000"/>
-              </a:spcAft>
-              <a:defRPr sz="1800">
-                <a:solidFill>
-                  <a:srgbClr val="F1F5F9"/>
-                </a:solidFill>
-              </a:defRPr>
-            </a:pPr>
-            <a:r>
-              <a:t>Đánh giá hiệu năng: Root Mean Squared Error (RMSE) = 1.58, Mean Absolute Error (MAE) = 1.23.</a:t>
-            </a:r>
-          </a:p>
-          <a:p>
-            <a:pPr>
-              <a:spcAft>
-                <a:spcPts val="1000"/>
-              </a:spcAft>
-              <a:defRPr sz="1800">
-                <a:solidFill>
-                  <a:srgbClr val="F1F5F9"/>
-                </a:solidFill>
-              </a:defRPr>
-            </a:pPr>
-            <a:r>
-              <a:t>Tính năng sản phẩm:</a:t>
-            </a:r>
-          </a:p>
-          <a:p>
-            <a:pPr>
-              <a:spcAft>
-                <a:spcPts val="1000"/>
-              </a:spcAft>
-              <a:defRPr sz="1800">
-                <a:solidFill>
-                  <a:srgbClr val="F1F5F9"/>
-                </a:solidFill>
-              </a:defRPr>
-            </a:pPr>
-            <a:r>
-              <a:t>  • Gợi ý Top 5 sản phẩm cá nhân hóa phù hợp với sở thích từng Customer ID.</a:t>
-            </a:r>
-          </a:p>
-          <a:p>
-            <a:pPr>
-              <a:spcAft>
-                <a:spcPts val="1000"/>
-              </a:spcAft>
-              <a:defRPr sz="1800">
-                <a:solidFill>
-                  <a:srgbClr val="F1F5F9"/>
-                </a:solidFill>
-              </a:defRPr>
-            </a:pPr>
-            <a:r>
-              <a:t>  • Gợi ý sản phẩm tương tự ('Khách hàng mua món này cũng xem món khác') dựa trên tương quan ngữ nghĩa &amp; mức giá.</a:t>
+              <a:t>Mục tiêu: Tự động phân loại 2,307 sản phẩm theo đặc tính giá, lượng bán, đánh giá và khuyến mãi.</a:t>
+            </a:r>
+          </a:p>
+          <a:p>
+            <a:pPr>
+              <a:spcAft>
+                <a:spcPts val="1000"/>
+              </a:spcAft>
+              <a:defRPr sz="1800">
+                <a:solidFill>
+                  <a:srgbClr val="F1F5F9"/>
+                </a:solidFill>
+              </a:defRPr>
+            </a:pPr>
+            <a:r>
+              <a:t>Kết quả 4 cụm sản phẩm chiến lược:</a:t>
+            </a:r>
+          </a:p>
+          <a:p>
+            <a:pPr>
+              <a:spcAft>
+                <a:spcPts val="1000"/>
+              </a:spcAft>
+              <a:defRPr sz="1800">
+                <a:solidFill>
+                  <a:srgbClr val="F1F5F9"/>
+                </a:solidFill>
+              </a:defRPr>
+            </a:pPr>
+            <a:r>
+              <a:t>  1. Cụm 'Ngôi Sao Doanh Số' (Sales Champions): Lượng bán cực cao, rating 4.8★ -&gt; Ưu tiên xuất hiện trang chủ.</a:t>
+            </a:r>
+          </a:p>
+          <a:p>
+            <a:pPr>
+              <a:spcAft>
+                <a:spcPts val="1000"/>
+              </a:spcAft>
+              <a:defRPr sz="1800">
+                <a:solidFill>
+                  <a:srgbClr val="F1F5F9"/>
+                </a:solidFill>
+              </a:defRPr>
+            </a:pPr>
+            <a:r>
+              <a:t>  2. Cụm 'Sản Phẩm Cao Cấp' (Flagship Premium): Đơn giá rất cao, mang lại GMV lớn -&gt; Tặng gói TikiNow 2h VIP.</a:t>
+            </a:r>
+          </a:p>
+          <a:p>
+            <a:pPr>
+              <a:spcAft>
+                <a:spcPts val="1000"/>
+              </a:spcAft>
+              <a:defRPr sz="1800">
+                <a:solidFill>
+                  <a:srgbClr val="F1F5F9"/>
+                </a:solidFill>
+              </a:defRPr>
+            </a:pPr>
+            <a:r>
+              <a:t>  3. Cụm 'Khuyến Mãi Mạnh' (Deep Discount): Tỷ lệ giảm giá &gt; 40% -&gt; Kéo lượng truy cập (Traffic Drivers).</a:t>
+            </a:r>
+          </a:p>
+          <a:p>
+            <a:pPr>
+              <a:spcAft>
+                <a:spcPts val="1000"/>
+              </a:spcAft>
+              <a:defRPr sz="1800">
+                <a:solidFill>
+                  <a:srgbClr val="F1F5F9"/>
+                </a:solidFill>
+              </a:defRPr>
+            </a:pPr>
+            <a:r>
+              <a:t>  4. Cụm 'Sản Phẩm Tiêu Chuẩn' (Long-tail Standard): Danh mục phủ rộng ổn định -&gt; Tối ưu chi phí lưu kho.</a:t>
             </a:r>
           </a:p>
         </p:txBody>
@@ -5108,7 +5168,7 @@
               </a:defRPr>
             </a:pPr>
             <a:r>
-              <a:t>7. Phân Cụm Khách Hàng RFM (Customer Segmentation)</a:t>
+              <a:t>7. Hệ Thống Gợi Ý Sản Phẩm Cá Nhân Hóa (Spark MLlib ALS)</a:t>
             </a:r>
           </a:p>
         </p:txBody>
@@ -5146,82 +5206,82 @@
               </a:defRPr>
             </a:pPr>
             <a:r>
-              <a:t>Mô hình RFM: Tính toán 3 chỉ số Recency (R), Frequency (F), Monetary (M) cho từng khách hàng.</a:t>
-            </a:r>
-          </a:p>
-          <a:p>
-            <a:pPr>
-              <a:spcAft>
-                <a:spcPts val="1000"/>
-              </a:spcAft>
-              <a:defRPr sz="1800">
-                <a:solidFill>
-                  <a:srgbClr val="F1F5F9"/>
-                </a:solidFill>
-              </a:defRPr>
-            </a:pPr>
-            <a:r>
-              <a:t>Phân cụm 4 phân khúc khách hàng chiến lược:</a:t>
-            </a:r>
-          </a:p>
-          <a:p>
-            <a:pPr>
-              <a:spcAft>
-                <a:spcPts val="1000"/>
-              </a:spcAft>
-              <a:defRPr sz="1800">
-                <a:solidFill>
-                  <a:srgbClr val="F1F5F9"/>
-                </a:solidFill>
-              </a:defRPr>
-            </a:pPr>
-            <a:r>
-              <a:t>  1. Champions / VIP (15%): Khách hàng trung thành, chi tiêu lớn -&gt; Tặng đặc quyền TikiNow VIP.</a:t>
-            </a:r>
-          </a:p>
-          <a:p>
-            <a:pPr>
-              <a:spcAft>
-                <a:spcPts val="1000"/>
-              </a:spcAft>
-              <a:defRPr sz="1800">
-                <a:solidFill>
-                  <a:srgbClr val="F1F5F9"/>
-                </a:solidFill>
-              </a:defRPr>
-            </a:pPr>
-            <a:r>
-              <a:t>  2. Potential Loyalists (30%): Tiềm năng cao -&gt; Đẩy mạnh Cross-selling từ mô hình ALS.</a:t>
-            </a:r>
-          </a:p>
-          <a:p>
-            <a:pPr>
-              <a:spcAft>
-                <a:spcPts val="1000"/>
-              </a:spcAft>
-              <a:defRPr sz="1800">
-                <a:solidFill>
-                  <a:srgbClr val="F1F5F9"/>
-                </a:solidFill>
-              </a:defRPr>
-            </a:pPr>
-            <a:r>
-              <a:t>  3. Promising Explorers (35%): Khách mới -&gt; Thông báo khuyến mãi danh mục bán chạy.</a:t>
-            </a:r>
-          </a:p>
-          <a:p>
-            <a:pPr>
-              <a:spcAft>
-                <a:spcPts val="1000"/>
-              </a:spcAft>
-              <a:defRPr sz="1800">
-                <a:solidFill>
-                  <a:srgbClr val="F1F5F9"/>
-                </a:solidFill>
-              </a:defRPr>
-            </a:pPr>
-            <a:r>
-              <a:t>  4. At Risk (20%): Nguy cơ rời bỏ -&gt; Chiến dịch Win-back email tặng voucher giảm giá 20%.</a:t>
+              <a:t>Thuật toán: Alternating Least Squares (ALS) phân rã ma trận tương tác User - Product (Matrix Factorization).</a:t>
+            </a:r>
+          </a:p>
+          <a:p>
+            <a:pPr>
+              <a:spcAft>
+                <a:spcPts val="1000"/>
+              </a:spcAft>
+              <a:defRPr sz="1800">
+                <a:solidFill>
+                  <a:srgbClr val="F1F5F9"/>
+                </a:solidFill>
+              </a:defRPr>
+            </a:pPr>
+            <a:r>
+              <a:t>Cấu hình mô hình: Latent Factors = 20, Regularization Param = 0.05, Train/Test Split = 80/20.</a:t>
+            </a:r>
+          </a:p>
+          <a:p>
+            <a:pPr>
+              <a:spcAft>
+                <a:spcPts val="1000"/>
+              </a:spcAft>
+              <a:defRPr sz="1800">
+                <a:solidFill>
+                  <a:srgbClr val="F1F5F9"/>
+                </a:solidFill>
+              </a:defRPr>
+            </a:pPr>
+            <a:r>
+              <a:t>Đánh giá hiệu năng: Root Mean Squared Error (RMSE) = 1.58, Mean Absolute Error (MAE) = 1.23.</a:t>
+            </a:r>
+          </a:p>
+          <a:p>
+            <a:pPr>
+              <a:spcAft>
+                <a:spcPts val="1000"/>
+              </a:spcAft>
+              <a:defRPr sz="1800">
+                <a:solidFill>
+                  <a:srgbClr val="F1F5F9"/>
+                </a:solidFill>
+              </a:defRPr>
+            </a:pPr>
+            <a:r>
+              <a:t>Tính năng triển khai:</a:t>
+            </a:r>
+          </a:p>
+          <a:p>
+            <a:pPr>
+              <a:spcAft>
+                <a:spcPts val="1000"/>
+              </a:spcAft>
+              <a:defRPr sz="1800">
+                <a:solidFill>
+                  <a:srgbClr val="F1F5F9"/>
+                </a:solidFill>
+              </a:defRPr>
+            </a:pPr>
+            <a:r>
+              <a:t>  • Gợi ý Top 5 sản phẩm cá nhân hóa phù hợp sở thích người dùng.</a:t>
+            </a:r>
+          </a:p>
+          <a:p>
+            <a:pPr>
+              <a:spcAft>
+                <a:spcPts val="1000"/>
+              </a:spcAft>
+              <a:defRPr sz="1800">
+                <a:solidFill>
+                  <a:srgbClr val="F1F5F9"/>
+                </a:solidFill>
+              </a:defRPr>
+            </a:pPr>
+            <a:r>
+              <a:t>  • Gợi ý sản phẩm tương tự ('Khách hàng xem món này cũng quan tâm') theo cùng phân khúc giá và cụm K-Means.</a:t>
             </a:r>
           </a:p>
         </p:txBody>
@@ -5317,7 +5377,7 @@
               </a:defRPr>
             </a:pPr>
             <a:r>
-              <a:t>8. Xử Lý Luồng Sự Kiện Thời Gian Thực (Streaming)</a:t>
+              <a:t>8. Xử Lý Luồng Sự Kiện Thời Gian Thực (Spark Streaming)</a:t>
             </a:r>
           </a:p>
         </p:txBody>
@@ -5355,7 +5415,7 @@
               </a:defRPr>
             </a:pPr>
             <a:r>
-              <a:t>Mô phỏng nguồn phát sự kiện: Kafka Producer phát luồng Clickstream (View, Add-to-cart, Purchase).</a:t>
+              <a:t>Mô phỏng nguồn phát sự kiện: Kafka Producer phát luồng Clickstream sản phẩm (Xem, Thêm giỏ, Đặt hàng).</a:t>
             </a:r>
           </a:p>
           <a:p>
@@ -5415,7 +5475,7 @@
               </a:defRPr>
             </a:pPr>
             <a:r>
-              <a:t>  • Giám sát tỷ lệ chuyển đổi giỏ hàng (Conversion Funnel: View -&gt; Add to Cart -&gt; Purchase).</a:t>
+              <a:t>  • Giám sát tỷ lệ chuyển đổi giỏ hàng (Conversion Funnel: View -&gt; Cart -&gt; Purchase).</a:t>
             </a:r>
           </a:p>
           <a:p>

</xml_diff>